<commit_message>
Update slide deck text and generator for retrieval, decision memory, evaluation and UI changes
Edited the committed .pptx in place (text only) and mirrored the text in build_media.py SLIDES.

Co-Authored-By: Claude Sonnet 5.5 <noreply@anthropic.com>
</commit_message>
<xml_diff>
--- a/submission/media/AEGIS_Slide_Deck.pptx
+++ b/submission/media/AEGIS_Slide_Deck.pptx
@@ -4189,7 +4189,7 @@
                   <a:srgbClr val="E6ECF5"/>
                 </a:solidFill>
               </a:rPr>
-              <a:t>Judge examples (recorded Nemotron responses, offline sample path): catalytic converters give 3 WEAK links with reasons a series can't be asserted; safe burglaries and keyless relay end in 'no supportable link'.</a:t>
+              <a:t>Judge examples (recorded Nemotron responses) predate the retrieval change: offline now falls back to a labelled code-only path for non-matching prompts. Not re-recorded; that needs live credentials.</a:t>
             </a:r>
           </a:p>
           <a:p>
@@ -4209,7 +4209,7 @@
                   <a:srgbClr val="E6ECF5"/>
                 </a:solidFill>
               </a:rPr>
-              <a:t>Live run through Docker with real Zetaris and Nightshift: full loop, real Nemotron on all four agents, zero partial failures. A live safe-burglary run retrieved the planted pair but the verifier and Skeptic refused an ungrounded link.</a:t>
+              <a:t>Reported by the team (trace not committed): live run through Docker with real Zetaris and Nightshift, before the retrieval change: full loop, real Nemotron on all four agents, zero partial failures. A live safe-burglary run retrieved the planted pair but the verifier and Skeptic refused an ungrounded link.</a:t>
             </a:r>
           </a:p>
           <a:p>
@@ -4229,7 +4229,7 @@
                   <a:srgbClr val="E6ECF5"/>
                 </a:solidFill>
               </a:rPr>
-              <a:t>We do not claim a model benchmark. evaluation/results.json used a scripted offline stand-in for the models, so it tests the pipeline and scoring mechanics, not model quality.</a:t>
+              <a:t>No model benchmark is claimed. A pre-registered evaluation and a --live harness exist but have not been run; evaluation/results.json is a scripted stand-in, so there is no real-model result.</a:t>
             </a:r>
           </a:p>
           <a:p>
@@ -4249,7 +4249,7 @@
                   <a:srgbClr val="E6ECF5"/>
                 </a:solidFill>
               </a:rPr>
-              <a:t>Engineering: 201 test functions; one command (pytest backend/tests tests) passes, engine and live tests skip when unavailable; secret scan on source and image; CI runs the judge path and --network none.</a:t>
+              <a:t>Engineering: pytest backend/tests tests gives 284 passed, 7 skipped (run on this build, SAMPLE_MODE, engines built); secret scan on source and image; CI runs the judge path and --network none.</a:t>
             </a:r>
           </a:p>
         </p:txBody>
@@ -4501,7 +4501,7 @@
                   <a:srgbClr val="E6ECF5"/>
                 </a:solidFill>
               </a:rPr>
-              <a:t>Scores are labelled uncalibrated heuristics.</a:t>
+              <a:t>Scores are labelled uncalibrated heuristics; the UI no longer hard-codes certainty claims, statuses come from the API response.</a:t>
             </a:r>
           </a:p>
           <a:p>
@@ -4521,7 +4521,7 @@
                   <a:srgbClr val="E6ECF5"/>
                 </a:solidFill>
               </a:rPr>
-              <a:t>Transparent degradation: replayed, code-fallback and local-sample steps are labelled in the trace.</a:t>
+              <a:t>Transparent degradation: replayed, code-fallback and local-sample steps are labelled in the trace. Decision-memory influence is traced.</a:t>
             </a:r>
           </a:p>
           <a:p>
@@ -4733,7 +4733,7 @@
                   <a:srgbClr val="E6ECF5"/>
                 </a:solidFill>
               </a:rPr>
-              <a:t>Next: semantic retrieval and reranking once the routes are served; CCTV vision; crime-specific Scout intents; streamed progress; bound SQL parameters; calibrated confidence; larger multi-run benchmark with real Nemotron; analyst feedback.</a:t>
+              <a:t>Next: semantic retrieval once the routes are served; run the pre-registered --live evaluation; re-record fixtures; CCTV vision; crime-specific Scout intents; streamed progress; bound SQL parameters; calibrated confidence; analyst feedback.</a:t>
             </a:r>
           </a:p>
           <a:p>
@@ -4753,7 +4753,7 @@
                   <a:srgbClr val="E6ECF5"/>
                 </a:solidFill>
               </a:rPr>
-              <a:t>Limits: synthetic data; only H-MEM and Markovian run in the image; World Model and Scout need a mounted Nightshift engine directory; verifier heuristics cover known patterns; Ultra is slow; sample-mode quality depends on recorded fixtures.</a:t>
+              <a:t>Limits: synthetic data; 7-case dev set; INC-NORTH-0294 still missed by retrieval; fixtures need re-recording; new SQL and UI changes untested live; only H-MEM and Markovian run in the image; World Model and Scout need a mounted engine directory; Ultra is slow.</a:t>
             </a:r>
           </a:p>
           <a:p>
@@ -6369,7 +6369,7 @@
                   <a:srgbClr val="E6ECF5"/>
                 </a:solidFill>
               </a:rPr>
-              <a:t>The model never touches the database: it sees at most 14 incidents and 8 records per source, and every ID it cites is re-checked.</a:t>
+              <a:t>Retrieval is relevance-scored: a bounded pool (80 rows max), IDF re-rank, corroboration-aware. This SQL has not been run against live Zetaris; only the local-sample mirror is tested.</a:t>
             </a:r>
           </a:p>
           <a:p>
@@ -6389,7 +6389,27 @@
                   <a:srgbClr val="E6ECF5"/>
                 </a:solidFill>
               </a:rPr>
-              <a:t>Verified live from inside Docker: data_mode zetaris_live, real query UUIDs, all five tables.</a:t>
+              <a:t>The model never touches the database: it sees at most 14 incidents and 8 records per source, and every ID it cites is re-checked.</a:t>
+            </a:r>
+          </a:p>
+          <a:p>
+            <a:pPr>
+              <a:spcAft>
+                <a:spcPts val="900"/>
+              </a:spcAft>
+              <a:defRPr sz="1700" b="0">
+                <a:solidFill>
+                  <a:srgbClr val="E6ECF5"/>
+                </a:solidFill>
+              </a:defRPr>
+            </a:pPr>
+            <a:r>
+              <a:rPr sz="1700" b="0">
+                <a:solidFill>
+                  <a:srgbClr val="E6ECF5"/>
+                </a:solidFill>
+              </a:rPr>
+              <a:t>Live run from inside Docker (reported by the team; trace not committed, before this change): data_mode zetaris_live, query UUIDs, all five tables.</a:t>
             </a:r>
           </a:p>
           <a:p>
@@ -6589,14 +6609,14 @@
               <a:spcAft>
                 <a:spcPts val="900"/>
               </a:spcAft>
-              <a:defRPr sz="1600" b="0">
-                <a:solidFill>
-                  <a:srgbClr val="E6ECF5"/>
-                </a:solidFill>
-              </a:defRPr>
-            </a:pPr>
-            <a:r>
-              <a:rPr sz="1600" b="0">
+              <a:defRPr sz="1500" b="0">
+                <a:solidFill>
+                  <a:srgbClr val="E6ECF5"/>
+                </a:solidFill>
+              </a:defRPr>
+            </a:pPr>
+            <a:r>
+              <a:rPr sz="1500" b="0">
                 <a:solidFill>
                   <a:srgbClr val="E6ECF5"/>
                 </a:solidFill>
@@ -6609,19 +6629,19 @@
               <a:spcAft>
                 <a:spcPts val="900"/>
               </a:spcAft>
-              <a:defRPr sz="1600" b="0">
-                <a:solidFill>
-                  <a:srgbClr val="E6ECF5"/>
-                </a:solidFill>
-              </a:defRPr>
-            </a:pPr>
-            <a:r>
-              <a:rPr sz="1600" b="0">
-                <a:solidFill>
-                  <a:srgbClr val="E6ECF5"/>
-                </a:solidFill>
-              </a:rPr>
-              <a:t>H-MEM: recalls vetted leads as context only; stores only verified, Skeptic-reviewed leads (0.6 floor, secret gate). (test_engine_adapters.py, test_reference_engines.py)</a:t>
+              <a:defRPr sz="1500" b="0">
+                <a:solidFill>
+                  <a:srgbClr val="E6ECF5"/>
+                </a:solidFill>
+              </a:defRPr>
+            </a:pPr>
+            <a:r>
+              <a:rPr sz="1500" b="0">
+                <a:solidFill>
+                  <a:srgbClr val="E6ECF5"/>
+                </a:solidFill>
+              </a:rPr>
+              <a:t>H-MEM: recalls vetted leads as context only; stores only verified, Skeptic-reviewed leads (0.6 floor, secret gate). Decision memory: see slide 9. (test_engine_adapters.py, test_reference_engines.py)</a:t>
             </a:r>
           </a:p>
           <a:p>
@@ -6629,14 +6649,14 @@
               <a:spcAft>
                 <a:spcPts val="900"/>
               </a:spcAft>
-              <a:defRPr sz="1600" b="0">
-                <a:solidFill>
-                  <a:srgbClr val="E6ECF5"/>
-                </a:solidFill>
-              </a:defRPr>
-            </a:pPr>
-            <a:r>
-              <a:rPr sz="1600" b="0">
+              <a:defRPr sz="1500" b="0">
+                <a:solidFill>
+                  <a:srgbClr val="E6ECF5"/>
+                </a:solidFill>
+              </a:defRPr>
+            </a:pPr>
+            <a:r>
+              <a:rPr sz="1500" b="0">
                 <a:solidFill>
                   <a:srgbClr val="E6ECF5"/>
                 </a:solidFill>
@@ -6649,14 +6669,14 @@
               <a:spcAft>
                 <a:spcPts val="900"/>
               </a:spcAft>
-              <a:defRPr sz="1600" b="0">
-                <a:solidFill>
-                  <a:srgbClr val="E6ECF5"/>
-                </a:solidFill>
-              </a:defRPr>
-            </a:pPr>
-            <a:r>
-              <a:rPr sz="1600" b="0">
+              <a:defRPr sz="1500" b="0">
+                <a:solidFill>
+                  <a:srgbClr val="E6ECF5"/>
+                </a:solidFill>
+              </a:defRPr>
+            </a:pPr>
+            <a:r>
+              <a:rPr sz="1500" b="0">
                 <a:solidFill>
                   <a:srgbClr val="E6ECF5"/>
                 </a:solidFill>
@@ -6669,14 +6689,14 @@
               <a:spcAft>
                 <a:spcPts val="900"/>
               </a:spcAft>
-              <a:defRPr sz="1600" b="0">
-                <a:solidFill>
-                  <a:srgbClr val="E6ECF5"/>
-                </a:solidFill>
-              </a:defRPr>
-            </a:pPr>
-            <a:r>
-              <a:rPr sz="1600" b="0">
+              <a:defRPr sz="1500" b="0">
+                <a:solidFill>
+                  <a:srgbClr val="E6ECF5"/>
+                </a:solidFill>
+              </a:defRPr>
+            </a:pPr>
+            <a:r>
+              <a:rPr sz="1500" b="0">
                 <a:solidFill>
                   <a:srgbClr val="E6ECF5"/>
                 </a:solidFill>
@@ -7189,7 +7209,7 @@
                   <a:srgbClr val="E6ECF5"/>
                 </a:solidFill>
               </a:rPr>
-              <a:t>3. 'Memory only learns what survived scrutiny.' H-MEM stores only verified, Skeptic-reviewed leads; runs checkpoint and resume.</a:t>
+              <a:t>3. 'Memory only learns what survived scrutiny.' H-MEM stores only verified, Skeptic-reviewed leads. Decision memory: such a lead can change a later retrieval order, attributed in the trace, never evidence (scripted-model tests only).</a:t>
             </a:r>
           </a:p>
           <a:p>

</xml_diff>